<commit_message>
Replace brain icons with posterior fossa tumor illustration
Co-Authored-By: Claude Opus 5.5 <noreply@anthropic.com>
Claude-Session: https://claude.ai/code/session_016zyDW6T1x7w4TWJhWZZdRw
</commit_message>
<xml_diff>
--- a/UofU_Neurosurgery_Grand_Rounds_Template.pptx
+++ b/UofU_Neurosurgery_Grand_Rounds_Template.pptx
@@ -124,21 +124,21 @@
   <p:extLst>
     <p:ext uri="{521415D9-36F7-43E2-AB2F-B90AF26B5E84}">
       <p14:sectionLst xmlns:p14="http://schemas.microsoft.com/office/powerpoint/2010/main">
-        <p14:section name="Opening" id="{3ee065d1-dc1e-a35a-8fda-f857acabdd70}">
+        <p14:section name="Opening" id="{5691c9b6-c2d8-119d-522f-48728e0b8088}">
           <p14:sldIdLst>
             <p14:sldId id="256"/>
             <p14:sldId id="257"/>
             <p14:sldId id="258"/>
           </p14:sldIdLst>
         </p14:section>
-        <p14:section name="Case Presentation" id="{9d62c1fc-bf79-5a83-8f46-859921fb6feb}">
+        <p14:section name="Case Presentation" id="{aecb9fd9-b4be-106d-5286-abbeb85ca7cc}">
           <p14:sldIdLst>
             <p14:sldId id="259"/>
             <p14:sldId id="260"/>
             <p14:sldId id="261"/>
           </p14:sldIdLst>
         </p14:section>
-        <p14:section name="Background and Evidence" id="{5ba406f6-3d37-9895-6eba-dfc81e59a8ac}">
+        <p14:section name="Background and Evidence" id="{f83dfa1b-c434-3609-361e-5156d8e49653}">
           <p14:sldIdLst>
             <p14:sldId id="262"/>
             <p14:sldId id="263"/>
@@ -147,14 +147,14 @@
             <p14:sldId id="266"/>
           </p14:sldIdLst>
         </p14:section>
-        <p14:section name="Surgical Management" id="{46224624-3e8a-bf6b-4437-27f760439f4a}">
+        <p14:section name="Surgical Management" id="{256c1b74-264e-1bf2-032d-65acd999a982}">
           <p14:sldIdLst>
             <p14:sldId id="267"/>
             <p14:sldId id="268"/>
             <p14:sldId id="269"/>
           </p14:sldIdLst>
         </p14:section>
-        <p14:section name="Conclusion" id="{2ebcf0df-c343-193f-5faf-7eda98c28f4a}">
+        <p14:section name="Conclusion" id="{2804307c-ad7a-6cbf-0725-ab28c8061208}">
           <p14:sldIdLst>
             <p14:sldId id="270"/>
             <p14:sldId id="271"/>
@@ -2471,8 +2471,8 @@
         </p:blipFill>
         <p:spPr>
           <a:xfrm>
-            <a:off x="8394192" y="1920240"/>
-            <a:ext cx="3017520" cy="3017520"/>
+            <a:off x="8394192" y="1956816"/>
+            <a:ext cx="3017520" cy="2935224"/>
           </a:xfrm>
           <a:prstGeom prst="rect">
             <a:avLst/>
@@ -2740,8 +2740,8 @@
         </p:blipFill>
         <p:spPr>
           <a:xfrm>
-            <a:off x="7680960" y="914400"/>
-            <a:ext cx="5029200" cy="5029200"/>
+            <a:off x="7315200" y="1188720"/>
+            <a:ext cx="4572000" cy="4443984"/>
           </a:xfrm>
           <a:prstGeom prst="rect">
             <a:avLst/>
@@ -3406,8 +3406,8 @@
         </p:blipFill>
         <p:spPr>
           <a:xfrm>
-            <a:off x="5184648" y="822960"/>
-            <a:ext cx="1828800" cy="1828800"/>
+            <a:off x="5184648" y="868680"/>
+            <a:ext cx="1828800" cy="1783080"/>
           </a:xfrm>
           <a:prstGeom prst="rect">
             <a:avLst/>

</xml_diff>

<commit_message>
Show posterior fossa tumor within a child's head profile
Co-Authored-By: Claude Opus 5.5 <noreply@anthropic.com>
Claude-Session: https://claude.ai/code/session_016zyDW6T1x7w4TWJhWZZdRw
</commit_message>
<xml_diff>
--- a/UofU_Neurosurgery_Grand_Rounds_Template.pptx
+++ b/UofU_Neurosurgery_Grand_Rounds_Template.pptx
@@ -124,21 +124,21 @@
   <p:extLst>
     <p:ext uri="{521415D9-36F7-43E2-AB2F-B90AF26B5E84}">
       <p14:sectionLst xmlns:p14="http://schemas.microsoft.com/office/powerpoint/2010/main">
-        <p14:section name="Opening" id="{5691c9b6-c2d8-119d-522f-48728e0b8088}">
+        <p14:section name="Opening" id="{05a33297-808a-c868-e028-de9a0ebbf7ec}">
           <p14:sldIdLst>
             <p14:sldId id="256"/>
             <p14:sldId id="257"/>
             <p14:sldId id="258"/>
           </p14:sldIdLst>
         </p14:section>
-        <p14:section name="Case Presentation" id="{aecb9fd9-b4be-106d-5286-abbeb85ca7cc}">
+        <p14:section name="Case Presentation" id="{a510a5c0-b432-31a1-3fdf-31ad06b27973}">
           <p14:sldIdLst>
             <p14:sldId id="259"/>
             <p14:sldId id="260"/>
             <p14:sldId id="261"/>
           </p14:sldIdLst>
         </p14:section>
-        <p14:section name="Background and Evidence" id="{f83dfa1b-c434-3609-361e-5156d8e49653}">
+        <p14:section name="Background and Evidence" id="{22946fda-4193-ffb2-1a3e-f1f6a8b259e5}">
           <p14:sldIdLst>
             <p14:sldId id="262"/>
             <p14:sldId id="263"/>
@@ -147,14 +147,14 @@
             <p14:sldId id="266"/>
           </p14:sldIdLst>
         </p14:section>
-        <p14:section name="Surgical Management" id="{256c1b74-264e-1bf2-032d-65acd999a982}">
+        <p14:section name="Surgical Management" id="{d94e6b15-3844-7d38-1cad-0f7340d3e090}">
           <p14:sldIdLst>
             <p14:sldId id="267"/>
             <p14:sldId id="268"/>
             <p14:sldId id="269"/>
           </p14:sldIdLst>
         </p14:section>
-        <p14:section name="Conclusion" id="{2804307c-ad7a-6cbf-0725-ab28c8061208}">
+        <p14:section name="Conclusion" id="{943787b6-9aa3-7669-af73-6cc3bf15903e}">
           <p14:sldIdLst>
             <p14:sldId id="270"/>
             <p14:sldId id="271"/>
@@ -2471,8 +2471,8 @@
         </p:blipFill>
         <p:spPr>
           <a:xfrm>
-            <a:off x="8394192" y="1956816"/>
-            <a:ext cx="3017520" cy="2935224"/>
+            <a:off x="8138160" y="1508760"/>
+            <a:ext cx="3520440" cy="3840480"/>
           </a:xfrm>
           <a:prstGeom prst="rect">
             <a:avLst/>
@@ -2740,8 +2740,8 @@
         </p:blipFill>
         <p:spPr>
           <a:xfrm>
-            <a:off x="7315200" y="1188720"/>
-            <a:ext cx="4572000" cy="4443984"/>
+            <a:off x="7498080" y="914400"/>
+            <a:ext cx="4361688" cy="4754880"/>
           </a:xfrm>
           <a:prstGeom prst="rect">
             <a:avLst/>
@@ -3397,17 +3397,15 @@
           <p:nvPr/>
         </p:nvPicPr>
         <p:blipFill>
-          <a:blip r:embed="rId1">
-            <a:alphaModFix amt="80000"/>
-          </a:blip>
+          <a:blip r:embed="rId1"/>
           <a:stretch>
             <a:fillRect/>
           </a:stretch>
         </p:blipFill>
         <p:spPr>
           <a:xfrm>
-            <a:off x="5184648" y="868680"/>
-            <a:ext cx="1828800" cy="1783080"/>
+            <a:off x="5257800" y="822960"/>
+            <a:ext cx="1682496" cy="1828800"/>
           </a:xfrm>
           <a:prstGeom prst="rect">
             <a:avLst/>

</xml_diff>

<commit_message>
Restore original brain icon with irregular cerebellar tumor
Co-Authored-By: Claude Opus 5.5 <noreply@anthropic.com>
Claude-Session: https://claude.ai/code/session_016zyDW6T1x7w4TWJhWZZdRw
</commit_message>
<xml_diff>
--- a/UofU_Neurosurgery_Grand_Rounds_Template.pptx
+++ b/UofU_Neurosurgery_Grand_Rounds_Template.pptx
@@ -124,21 +124,21 @@
   <p:extLst>
     <p:ext uri="{521415D9-36F7-43E2-AB2F-B90AF26B5E84}">
       <p14:sectionLst xmlns:p14="http://schemas.microsoft.com/office/powerpoint/2010/main">
-        <p14:section name="Opening" id="{05a33297-808a-c868-e028-de9a0ebbf7ec}">
+        <p14:section name="Opening" id="{13df1a09-e0f1-5067-16d0-1bc11a46311e}">
           <p14:sldIdLst>
             <p14:sldId id="256"/>
             <p14:sldId id="257"/>
             <p14:sldId id="258"/>
           </p14:sldIdLst>
         </p14:section>
-        <p14:section name="Case Presentation" id="{a510a5c0-b432-31a1-3fdf-31ad06b27973}">
+        <p14:section name="Case Presentation" id="{736f8c74-3c94-2423-bd30-60ce92686b37}">
           <p14:sldIdLst>
             <p14:sldId id="259"/>
             <p14:sldId id="260"/>
             <p14:sldId id="261"/>
           </p14:sldIdLst>
         </p14:section>
-        <p14:section name="Background and Evidence" id="{22946fda-4193-ffb2-1a3e-f1f6a8b259e5}">
+        <p14:section name="Background and Evidence" id="{c077d292-b873-e9df-0f46-30ec28794673}">
           <p14:sldIdLst>
             <p14:sldId id="262"/>
             <p14:sldId id="263"/>
@@ -147,14 +147,14 @@
             <p14:sldId id="266"/>
           </p14:sldIdLst>
         </p14:section>
-        <p14:section name="Surgical Management" id="{d94e6b15-3844-7d38-1cad-0f7340d3e090}">
+        <p14:section name="Surgical Management" id="{eddc70a3-0d3f-b322-168b-c50ef0fef490}">
           <p14:sldIdLst>
             <p14:sldId id="267"/>
             <p14:sldId id="268"/>
             <p14:sldId id="269"/>
           </p14:sldIdLst>
         </p14:section>
-        <p14:section name="Conclusion" id="{943787b6-9aa3-7669-af73-6cc3bf15903e}">
+        <p14:section name="Conclusion" id="{eee9dcd6-4681-65a2-d4e3-3a131cad8491}">
           <p14:sldIdLst>
             <p14:sldId id="270"/>
             <p14:sldId id="271"/>
@@ -2471,8 +2471,8 @@
         </p:blipFill>
         <p:spPr>
           <a:xfrm>
-            <a:off x="8138160" y="1508760"/>
-            <a:ext cx="3520440" cy="3840480"/>
+            <a:off x="8394192" y="1920240"/>
+            <a:ext cx="3017520" cy="3017520"/>
           </a:xfrm>
           <a:prstGeom prst="rect">
             <a:avLst/>
@@ -2740,8 +2740,8 @@
         </p:blipFill>
         <p:spPr>
           <a:xfrm>
-            <a:off x="7498080" y="914400"/>
-            <a:ext cx="4361688" cy="4754880"/>
+            <a:off x="7680960" y="914400"/>
+            <a:ext cx="5029200" cy="5029200"/>
           </a:xfrm>
           <a:prstGeom prst="rect">
             <a:avLst/>
@@ -3404,8 +3404,8 @@
         </p:blipFill>
         <p:spPr>
           <a:xfrm>
-            <a:off x="5257800" y="822960"/>
-            <a:ext cx="1682496" cy="1828800"/>
+            <a:off x="5184648" y="822960"/>
+            <a:ext cx="1828800" cy="1828800"/>
           </a:xfrm>
           <a:prstGeom prst="rect">
             <a:avLst/>

</xml_diff>

<commit_message>
Use University of Utah Health logo in slide footer
Co-Authored-By: Claude Opus 5.5 <noreply@anthropic.com>
Claude-Session: https://claude.ai/code/session_016zyDW6T1x7w4TWJhWZZdRw
</commit_message>
<xml_diff>
--- a/UofU_Neurosurgery_Grand_Rounds_Template.pptx
+++ b/UofU_Neurosurgery_Grand_Rounds_Template.pptx
@@ -124,21 +124,21 @@
   <p:extLst>
     <p:ext uri="{521415D9-36F7-43E2-AB2F-B90AF26B5E84}">
       <p14:sectionLst xmlns:p14="http://schemas.microsoft.com/office/powerpoint/2010/main">
-        <p14:section name="Opening" id="{13df1a09-e0f1-5067-16d0-1bc11a46311e}">
+        <p14:section name="Opening" id="{953eb21a-afa2-cbaa-f37d-ebc5a3c41f5c}">
           <p14:sldIdLst>
             <p14:sldId id="256"/>
             <p14:sldId id="257"/>
             <p14:sldId id="258"/>
           </p14:sldIdLst>
         </p14:section>
-        <p14:section name="Case Presentation" id="{736f8c74-3c94-2423-bd30-60ce92686b37}">
+        <p14:section name="Case Presentation" id="{c83ee0a0-35fd-0679-417b-59826a09f031}">
           <p14:sldIdLst>
             <p14:sldId id="259"/>
             <p14:sldId id="260"/>
             <p14:sldId id="261"/>
           </p14:sldIdLst>
         </p14:section>
-        <p14:section name="Background and Evidence" id="{c077d292-b873-e9df-0f46-30ec28794673}">
+        <p14:section name="Background and Evidence" id="{776acd8c-4682-c450-ee9f-981f9bcb55c3}">
           <p14:sldIdLst>
             <p14:sldId id="262"/>
             <p14:sldId id="263"/>
@@ -147,14 +147,14 @@
             <p14:sldId id="266"/>
           </p14:sldIdLst>
         </p14:section>
-        <p14:section name="Surgical Management" id="{eddc70a3-0d3f-b322-168b-c50ef0fef490}">
+        <p14:section name="Surgical Management" id="{a678ec71-56a8-c1c7-aeba-d959a1c04219}">
           <p14:sldIdLst>
             <p14:sldId id="267"/>
             <p14:sldId id="268"/>
             <p14:sldId id="269"/>
           </p14:sldIdLst>
         </p14:section>
-        <p14:section name="Conclusion" id="{eee9dcd6-4681-65a2-d4e3-3a131cad8491}">
+        <p14:section name="Conclusion" id="{6999c5aa-5b37-d846-6feb-7131bf8f1154}">
           <p14:sldIdLst>
             <p14:sldId id="270"/>
             <p14:sldId id="271"/>
@@ -2895,35 +2895,39 @@
           </a:p>
         </p:txBody>
       </p:sp>
-      <p:sp>
-        <p:nvSpPr>
-          <p:cNvPr id="6" name="Shape 0"/>
+      <p:pic>
+        <p:nvPicPr>
+          <p:cNvPr id="6" name="Image 1" descr="University of Utah Health logo">    </p:cNvPr>
+          <p:cNvPicPr>
+            <a:picLocks noChangeAspect="1"/>
+          </p:cNvPicPr>
+          <p:nvPr/>
+        </p:nvPicPr>
+        <p:blipFill>
+          <a:blip r:embed="rId2"/>
+          <a:stretch>
+            <a:fillRect/>
+          </a:stretch>
+        </p:blipFill>
+        <p:spPr>
+          <a:xfrm>
+            <a:off x="548640" y="6336792"/>
+            <a:ext cx="329184" cy="329184"/>
+          </a:xfrm>
+          <a:prstGeom prst="rect">
+            <a:avLst/>
+          </a:prstGeom>
+        </p:spPr>
+      </p:pic>
+      <p:sp>
+        <p:nvSpPr>
+          <p:cNvPr id="7" name="Text 0"/>
           <p:cNvSpPr/>
           <p:nvPr/>
         </p:nvSpPr>
         <p:spPr>
           <a:xfrm>
-            <a:off x="548640" y="6428232"/>
-            <a:ext cx="146304" cy="146304"/>
-          </a:xfrm>
-          <a:prstGeom prst="rect">
-            <a:avLst/>
-          </a:prstGeom>
-          <a:solidFill>
-            <a:schemeClr val="accent1"/>
-          </a:solidFill>
-          <a:ln/>
-        </p:spPr>
-      </p:sp>
-      <p:sp>
-        <p:nvSpPr>
-          <p:cNvPr id="7" name="Text 1"/>
-          <p:cNvSpPr/>
-          <p:nvPr/>
-        </p:nvSpPr>
-        <p:spPr>
-          <a:xfrm>
-            <a:off x="777240" y="6355080"/>
+            <a:off x="987552" y="6355080"/>
             <a:ext cx="6400800" cy="292608"/>
           </a:xfrm>
           <a:prstGeom prst="rect">
@@ -3075,35 +3079,39 @@
           </a:p>
         </p:txBody>
       </p:sp>
-      <p:sp>
-        <p:nvSpPr>
-          <p:cNvPr id="3" name="Shape 0"/>
+      <p:pic>
+        <p:nvPicPr>
+          <p:cNvPr id="3" name="Image 0" descr="University of Utah Health logo">    </p:cNvPr>
+          <p:cNvPicPr>
+            <a:picLocks noChangeAspect="1"/>
+          </p:cNvPicPr>
+          <p:nvPr/>
+        </p:nvPicPr>
+        <p:blipFill>
+          <a:blip r:embed="rId1"/>
+          <a:stretch>
+            <a:fillRect/>
+          </a:stretch>
+        </p:blipFill>
+        <p:spPr>
+          <a:xfrm>
+            <a:off x="548640" y="6336792"/>
+            <a:ext cx="329184" cy="329184"/>
+          </a:xfrm>
+          <a:prstGeom prst="rect">
+            <a:avLst/>
+          </a:prstGeom>
+        </p:spPr>
+      </p:pic>
+      <p:sp>
+        <p:nvSpPr>
+          <p:cNvPr id="4" name="Text 0"/>
           <p:cNvSpPr/>
           <p:nvPr/>
         </p:nvSpPr>
         <p:spPr>
           <a:xfrm>
-            <a:off x="548640" y="6428232"/>
-            <a:ext cx="146304" cy="146304"/>
-          </a:xfrm>
-          <a:prstGeom prst="rect">
-            <a:avLst/>
-          </a:prstGeom>
-          <a:solidFill>
-            <a:schemeClr val="accent1"/>
-          </a:solidFill>
-          <a:ln/>
-        </p:spPr>
-      </p:sp>
-      <p:sp>
-        <p:nvSpPr>
-          <p:cNvPr id="4" name="Text 1"/>
-          <p:cNvSpPr/>
-          <p:nvPr/>
-        </p:nvSpPr>
-        <p:spPr>
-          <a:xfrm>
-            <a:off x="777240" y="6355080"/>
+            <a:off x="987552" y="6355080"/>
             <a:ext cx="6400800" cy="292608"/>
           </a:xfrm>
           <a:prstGeom prst="rect">
@@ -3255,35 +3263,39 @@
           </a:p>
         </p:txBody>
       </p:sp>
-      <p:sp>
-        <p:nvSpPr>
-          <p:cNvPr id="3" name="Shape 0"/>
+      <p:pic>
+        <p:nvPicPr>
+          <p:cNvPr id="3" name="Image 0" descr="University of Utah Health logo">    </p:cNvPr>
+          <p:cNvPicPr>
+            <a:picLocks noChangeAspect="1"/>
+          </p:cNvPicPr>
+          <p:nvPr/>
+        </p:nvPicPr>
+        <p:blipFill>
+          <a:blip r:embed="rId1"/>
+          <a:stretch>
+            <a:fillRect/>
+          </a:stretch>
+        </p:blipFill>
+        <p:spPr>
+          <a:xfrm>
+            <a:off x="548640" y="6336792"/>
+            <a:ext cx="329184" cy="329184"/>
+          </a:xfrm>
+          <a:prstGeom prst="rect">
+            <a:avLst/>
+          </a:prstGeom>
+        </p:spPr>
+      </p:pic>
+      <p:sp>
+        <p:nvSpPr>
+          <p:cNvPr id="4" name="Text 0"/>
           <p:cNvSpPr/>
           <p:nvPr/>
         </p:nvSpPr>
         <p:spPr>
           <a:xfrm>
-            <a:off x="548640" y="6428232"/>
-            <a:ext cx="146304" cy="146304"/>
-          </a:xfrm>
-          <a:prstGeom prst="rect">
-            <a:avLst/>
-          </a:prstGeom>
-          <a:solidFill>
-            <a:schemeClr val="accent1"/>
-          </a:solidFill>
-          <a:ln/>
-        </p:spPr>
-      </p:sp>
-      <p:sp>
-        <p:nvSpPr>
-          <p:cNvPr id="4" name="Text 1"/>
-          <p:cNvSpPr/>
-          <p:nvPr/>
-        </p:nvSpPr>
-        <p:spPr>
-          <a:xfrm>
-            <a:off x="777240" y="6355080"/>
+            <a:off x="987552" y="6355080"/>
             <a:ext cx="6400800" cy="292608"/>
           </a:xfrm>
           <a:prstGeom prst="rect">

</xml_diff>